<commit_message>
add github code examples link in the ebook summary
</commit_message>
<xml_diff>
--- a/ebook-Java-Bushido.pptx
+++ b/ebook-Java-Bushido.pptx
@@ -8278,7 +8278,7 @@
         <p:spPr>
           <a:xfrm>
             <a:off x="476249" y="2800000"/>
-            <a:ext cx="8635092" cy="6178999"/>
+            <a:ext cx="8635092" cy="7194662"/>
           </a:xfrm>
           <a:prstGeom prst="rect">
             <a:avLst/>
@@ -8600,6 +8600,42 @@
               <a:t> Honra no Código</a:t>
             </a:r>
             <a:endParaRPr lang="pt-BR" sz="2200" dirty="0">
+              <a:solidFill>
+                <a:srgbClr val="121212"/>
+              </a:solidFill>
+              <a:latin typeface="Calibri Light" panose="020F0302020204030204" pitchFamily="34" charset="0"/>
+            </a:endParaRPr>
+          </a:p>
+          <a:p>
+            <a:pPr>
+              <a:lnSpc>
+                <a:spcPct val="150000"/>
+              </a:lnSpc>
+            </a:pPr>
+            <a:endParaRPr lang="pt-BR" sz="2200" dirty="0">
+              <a:solidFill>
+                <a:srgbClr val="121212"/>
+              </a:solidFill>
+              <a:latin typeface="Calibri Light" panose="020F0302020204030204" pitchFamily="34" charset="0"/>
+            </a:endParaRPr>
+          </a:p>
+          <a:p>
+            <a:pPr>
+              <a:lnSpc>
+                <a:spcPct val="150000"/>
+              </a:lnSpc>
+            </a:pPr>
+            <a:r>
+              <a:rPr lang="pt-BR" sz="2200" b="1" dirty="0">
+                <a:solidFill>
+                  <a:srgbClr val="121212"/>
+                </a:solidFill>
+                <a:latin typeface="Calibri Light" panose="020F0302020204030204" pitchFamily="34" charset="0"/>
+                <a:hlinkClick r:id="rId11"/>
+              </a:rPr>
+              <a:t>Códigos de exemplo no GitHub</a:t>
+            </a:r>
+            <a:endParaRPr lang="pt-BR" sz="2200" b="1" dirty="0">
               <a:solidFill>
                 <a:srgbClr val="121212"/>
               </a:solidFill>

</xml_diff>